<commit_message>
M12: Sim-Review umgesetzt (sim_review true, Inhalt aktualisiert)
Co-Authored-By: Claude Opus 4.8 <noreply@anthropic.com>
</commit_message>
<xml_diff>
--- a/protected-downloads/praesentation/M12.pptx
+++ b/protected-downloads/praesentation/M12.pptx
@@ -583,7 +583,7 @@
           <a:lstStyle/>
           <a:p>
             <a:r>
-              <a:t>Moderation (HB Sec 3): Kern des Inputs: Warum CEO-Dialoge scheitern – und was strukturell anders ist. Fokus: McClelland &amp; Burnham (Q-154) zu Machtmotivation, Edmondson (Q-148) zu psychologischer Sicherheit. Visualisierung: „Gesprächsarchitektur eines CEO-Dialogs" auf Flipchart (3 Ebenen: Einstieg → Vertiefung → Commitment). Trainer-Hinweis: Kein akademischer Vortrag – jede Theorie an einem eigenen Erlebnis verankern. „Ich hatte mal einen Kunden, der nach 15 Jahren zum ersten Mal über sein Unternehmen gesprochen hat – weil ich eine andere Frage gestellt habe." Persönliche Glaubwürdigkeit ist die Eintrittskarte zur Stufe-4-Kompetenzentwicklung.</a:t>
+              <a:t>Moderation (HB Sec 3): Kern des Inputs: Warum CEO-Dialoge scheitern – und was strukturell anders ist. Fokus: McClelland &amp; Burnham (Q-154) zu Machtmotivation, Edmondson (Q-148) zu psychologischer Sicherheit. Visualisierung: „Gesprächsarchitektur eines CEO-Dialogs" auf Flipchart (3 Ebenen: Einstieg → Vertiefung → Commitment). Trainer-Hinweis: Kein akademischer Vortrag – jede Theorie an einem eigenen Erlebnis verankern. „Ich hatte mal einen Kunden, der nach 15 Jahren zum ersten Mal über sein Unternehmen gesprochen hat – weil ich eine andere Frage gestellt habe." Persönliche Glaubwürdigkeit ist die Eintrittskarte zur Stufe-4-Kompetenzentwicklung. Trainer-Hinweis Formulierungs-Kontraste: Das Board-Room-Mindset bleibt sonst abstrakt – machen Sie es an Sprache fest. Flipchart in zwei Spalten teilen: links „Dienstleister-Sprache" / rechts „Augenhöhe-Sprache" (Kontraste aus Sec 4.1 nutzen). Lassen Sie die TN zuerst ihre eigenen Einstiegsformulierungen für ein CEO-Gespräch nennen („Was sagen Sie, wenn Sie aktuell in ein CEO-Gespräch einsteigen?"), sammeln Sie diese in der linken Spalte und entwickeln Sie das Reframing rechts gemeinsam. Dauer: ca. 5 Minuten Extra-Interaktion – der Schritt von Prinzip zu Praxis, den der Vortrag allein nicht leistet.</a:t>
             </a:r>
           </a:p>
         </p:txBody>
@@ -653,7 +653,7 @@
           <a:lstStyle/>
           <a:p>
             <a:r>
-              <a:t>Moderation (HB Sec 3): Einführung der drei Kernwerkzeuge: 1. Wunderfrage (de Shazer, 1985 ): Angenommen, über Nacht wäre das Problem gelöst – was wäre morgen anders? 2. Zirkuläre Frage (Penn, 1982 ; Tomm, 1987 ): Was würde Ihr Steuerberater sagen, wenn ich ihn fragen würde, was Ihr größtes Hindernis ist? 3. Hypothetische Frage: Wenn Sie wüssten, dass Ihr Unternehmen in 5 Jahren verkauft wird – was würden Sie heute anders machen? Übung im Plenum: Jeder TN formuliert eine zirkuläre Frage für seinen wichtigsten Nachfolge-Kunden. Kurze Partnerdiskussion (5 min), dann zwei Beispiele im Plenum vorstellen.</a:t>
+              <a:t>Moderation (HB Sec 3): Einführung der drei Kernwerkzeuge: 1. Wunderfrage (de Shazer, 1985 ): Angenommen, über Nacht wäre das Problem gelöst – was wäre morgen anders? 2. Zirkuläre Frage (Penn, 1982 ; Tomm, 1987 ): Was würde Ihr Steuerberater sagen, wenn ich ihn fragen würde, was Ihr größtes Hindernis ist? 3. Hypothetische Frage: Wenn Sie wüssten, dass Ihr Unternehmen in 5 Jahren verkauft wird – was würden Sie heute anders machen? Übung im Plenum (pragmatisch, ohne Typ-Zwang): Jeder TN formuliert „eine Frage, die eine andere Perspektive ins Gespräch bringt – aus der Sicht einer Person, die nicht im Raum ist." Muss keine zirkuläre Frage im Lehrbuch-Sinne sein – Hauptsache, der TN verlässt die Ich-Perspektive des Unternehmers. Kurze Partnerdiskussion (5 min), dann zwei Beispiele im Plenum vorstellen. Wichtig: Nicht die korrekte Kategorie bewerten, sondern die Wirkung der Frage. Die Drei-Typen-Taxonomie ist eine Lernhilfe, kein Anwendungsraster (siehe Kasten in Sec 4.2).</a:t>
             </a:r>
           </a:p>
         </p:txBody>
@@ -6667,7 +6667,7 @@
                 </a:solidFill>
                 <a:latin typeface="Arial"/>
               </a:rPr>
-              <a:t>▸  Systemische und zirkuläre Fragetechniken einsetzen, um latente Zukunftsängste aufzudecken und psychologische Sicherheit herzustellen</a:t>
+              <a:t>▸  Die psychologische Gesprächsdynamik im CEO-Dialog analysieren und das Fragemuster nach systemischen und zirkulären Techniken strukturieren, um latente Zukunftsängste aufzudecken</a:t>
             </a:r>
           </a:p>
           <a:p>

</xml_diff>